<commit_message>
Fix deck: 'by DuckDuckGo' → 'A Proposal for QuackQuackMoo' + all DDG refs
</commit_message>
<xml_diff>
--- a/proposal/shield-ai-proposal.pptx
+++ b/proposal/shield-ai-proposal.pptx
@@ -1942,6 +1942,10 @@
           </a:solidFill>
           <a:ln/>
         </p:spPr>
+        <p:txBody>
+          <a:bodyPr/>
+          <a:p/>
+        </p:txBody>
       </p:sp>
       <p:sp>
         <p:nvSpPr>
@@ -1964,6 +1968,10 @@
           </a:solidFill>
           <a:ln/>
         </p:spPr>
+        <p:txBody>
+          <a:bodyPr/>
+          <a:p/>
+        </p:txBody>
       </p:sp>
       <p:pic>
         <p:nvPicPr>
@@ -2061,7 +2069,7 @@
                 <a:ea typeface="Calibri" pitchFamily="34" charset="-122"/>
                 <a:cs typeface="Calibri" pitchFamily="34" charset="-120"/>
               </a:rPr>
-              <a:t>by DuckDuckGo</a:t>
+              <a:t>A Proposal for QuackQuackMoo</a:t>
             </a:r>
             <a:endParaRPr lang="en-US" sz="1600" dirty="0"/>
           </a:p>
@@ -2198,6 +2206,10 @@
           </a:solidFill>
           <a:ln/>
         </p:spPr>
+        <p:txBody>
+          <a:bodyPr/>
+          <a:p/>
+        </p:txBody>
       </p:sp>
       <p:sp>
         <p:nvSpPr>
@@ -2220,6 +2232,10 @@
           </a:solidFill>
           <a:ln/>
         </p:spPr>
+        <p:txBody>
+          <a:bodyPr/>
+          <a:p/>
+        </p:txBody>
       </p:sp>
       <p:pic>
         <p:nvPicPr>
@@ -2320,7 +2336,7 @@
                 <a:ea typeface="Calibri" pitchFamily="34" charset="-122"/>
                 <a:cs typeface="Calibri" pitchFamily="34" charset="-120"/>
               </a:rPr>
-              <a:t>Shield AI transforms DuckDuckGo from a </a:t>
+              <a:t>Shield AI transforms QuackQuackMoo from a </a:t>
             </a:r>
             <a:pPr algn="ctr" indent="0" marL="0">
               <a:lnSpc>
@@ -2489,7 +2505,7 @@
                 <a:ea typeface="Calibri" pitchFamily="34" charset="-122"/>
                 <a:cs typeface="Calibri" pitchFamily="34" charset="-120"/>
               </a:rPr>
-              <a:t>CONFIDENTIAL  •  SHIELD AI  •  PREPARED FOR DUCKDUCKGO</a:t>
+              <a:t>CONFIDENTIAL  •  SHIELD AI  •  PREPARED FOR QUACKQUACKMOO</a:t>
             </a:r>
             <a:endParaRPr lang="en-US" sz="900" dirty="0"/>
           </a:p>
@@ -2602,7 +2618,7 @@
                 <a:ea typeface="Calibri" pitchFamily="34" charset="-122"/>
                 <a:cs typeface="Calibri" pitchFamily="34" charset="-120"/>
               </a:rPr>
-              <a:t>Shield AI transforms DuckDuckGo from a $100M privacy search company into a $1B+ AI platform company — using a capital-efficient buy-and-self-host strategy that reduces the build to $1.5–3M with a $15–30K validation sprint to derisk before engineering begins.</a:t>
+              <a:t>Shield AI transforms QuackQuackMoo from a $100M privacy search company into a $1B+ AI platform company — using a capital-efficient buy-and-self-host strategy that reduces the build to $1.5–3M with a $15–30K validation sprint to derisk before engineering begins.</a:t>
             </a:r>
             <a:endParaRPr lang="en-US" sz="1500" dirty="0"/>
           </a:p>
@@ -2634,6 +2650,10 @@
             </a:outerShdw>
           </a:effectLst>
         </p:spPr>
+        <p:txBody>
+          <a:bodyPr/>
+          <a:p/>
+        </p:txBody>
       </p:sp>
       <p:sp>
         <p:nvSpPr>
@@ -2656,6 +2676,10 @@
           </a:solidFill>
           <a:ln/>
         </p:spPr>
+        <p:txBody>
+          <a:bodyPr/>
+          <a:p/>
+        </p:txBody>
       </p:sp>
       <p:pic>
         <p:nvPicPr>
@@ -2753,7 +2777,7 @@
                 <a:ea typeface="Calibri" pitchFamily="34" charset="-122"/>
                 <a:cs typeface="Calibri" pitchFamily="34" charset="-120"/>
               </a:rPr>
-              <a:t>DDG Users</a:t>
+              <a:t>QQM Users</a:t>
             </a:r>
             <a:endParaRPr lang="en-US" sz="1200" dirty="0"/>
           </a:p>
@@ -2785,6 +2809,10 @@
             </a:outerShdw>
           </a:effectLst>
         </p:spPr>
+        <p:txBody>
+          <a:bodyPr/>
+          <a:p/>
+        </p:txBody>
       </p:sp>
       <p:sp>
         <p:nvSpPr>
@@ -2807,6 +2835,10 @@
           </a:solidFill>
           <a:ln/>
         </p:spPr>
+        <p:txBody>
+          <a:bodyPr/>
+          <a:p/>
+        </p:txBody>
       </p:sp>
       <p:pic>
         <p:nvPicPr>
@@ -2936,6 +2968,10 @@
             </a:outerShdw>
           </a:effectLst>
         </p:spPr>
+        <p:txBody>
+          <a:bodyPr/>
+          <a:p/>
+        </p:txBody>
       </p:sp>
       <p:sp>
         <p:nvSpPr>
@@ -2958,6 +2994,10 @@
           </a:solidFill>
           <a:ln/>
         </p:spPr>
+        <p:txBody>
+          <a:bodyPr/>
+          <a:p/>
+        </p:txBody>
       </p:sp>
       <p:pic>
         <p:nvPicPr>
@@ -3082,6 +3122,10 @@
           </a:solidFill>
           <a:ln/>
         </p:spPr>
+        <p:txBody>
+          <a:bodyPr/>
+          <a:p/>
+        </p:txBody>
       </p:sp>
       <p:sp>
         <p:nvSpPr>
@@ -3119,7 +3163,7 @@
                 <a:ea typeface="Calibri" pitchFamily="34" charset="-122"/>
                 <a:cs typeface="Calibri" pitchFamily="34" charset="-120"/>
               </a:rPr>
-              <a:t>No competitor occupies this intersection. OpenAI and Google will never lead with privacy. Abacus AI has no privacy story. DuckDuckGo is the only company that can credibly ship a privacy-first AI super-platform.</a:t>
+              <a:t>No competitor occupies this intersection. OpenAI and Google will never lead with privacy. Abacus AI has no privacy story. QuackQuackMoo is the only company that can credibly ship a privacy-first AI super-platform.</a:t>
             </a:r>
             <a:endParaRPr lang="en-US" sz="1200" dirty="0"/>
           </a:p>
@@ -3222,6 +3266,10 @@
             </a:outerShdw>
           </a:effectLst>
         </p:spPr>
+        <p:txBody>
+          <a:bodyPr/>
+          <a:p/>
+        </p:txBody>
       </p:sp>
       <p:sp>
         <p:nvSpPr>
@@ -3244,6 +3292,10 @@
           </a:solidFill>
           <a:ln/>
         </p:spPr>
+        <p:txBody>
+          <a:bodyPr/>
+          <a:p/>
+        </p:txBody>
       </p:sp>
       <p:pic>
         <p:nvPicPr>
@@ -3476,6 +3528,10 @@
             </a:outerShdw>
           </a:effectLst>
         </p:spPr>
+        <p:txBody>
+          <a:bodyPr/>
+          <a:p/>
+        </p:txBody>
       </p:sp>
       <p:sp>
         <p:nvSpPr>
@@ -3498,6 +3554,10 @@
           </a:solidFill>
           <a:ln/>
         </p:spPr>
+        <p:txBody>
+          <a:bodyPr/>
+          <a:p/>
+        </p:txBody>
       </p:sp>
       <p:pic>
         <p:nvPicPr>
@@ -3556,7 +3616,7 @@
                 <a:ea typeface="Trebuchet MS" pitchFamily="34" charset="-122"/>
                 <a:cs typeface="Trebuchet MS" pitchFamily="34" charset="-120"/>
               </a:rPr>
-              <a:t>What DDG Uniquely Owns</a:t>
+              <a:t>What QQM Uniquely Owns</a:t>
             </a:r>
             <a:endParaRPr lang="en-US" sz="1600" dirty="0"/>
           </a:p>
@@ -3847,7 +3907,7 @@
                 <a:ea typeface="Calibri" pitchFamily="34" charset="-122"/>
                 <a:cs typeface="Calibri" pitchFamily="34" charset="-120"/>
               </a:rPr>
-              <a:t>What Shield AI delivers beyond Duck.ai chat</a:t>
+              <a:t>What Shield AI delivers beyond Quack.ai chat</a:t>
             </a:r>
             <a:endParaRPr lang="en-US" sz="1300" dirty="0"/>
           </a:p>
@@ -3872,6 +3932,10 @@
           </a:solidFill>
           <a:ln/>
         </p:spPr>
+        <p:txBody>
+          <a:bodyPr/>
+          <a:p/>
+        </p:txBody>
       </p:sp>
       <p:sp>
         <p:nvSpPr>
@@ -3892,6 +3956,10 @@
           </a:solidFill>
           <a:ln/>
         </p:spPr>
+        <p:txBody>
+          <a:bodyPr/>
+          <a:p/>
+        </p:txBody>
       </p:sp>
       <p:sp>
         <p:nvSpPr>
@@ -3914,6 +3982,10 @@
           </a:solidFill>
           <a:ln/>
         </p:spPr>
+        <p:txBody>
+          <a:bodyPr/>
+          <a:p/>
+        </p:txBody>
       </p:sp>
       <p:pic>
         <p:nvPicPr>
@@ -4075,6 +4147,10 @@
           </a:solidFill>
           <a:ln/>
         </p:spPr>
+        <p:txBody>
+          <a:bodyPr/>
+          <a:p/>
+        </p:txBody>
       </p:sp>
       <p:sp>
         <p:nvSpPr>
@@ -4095,6 +4171,10 @@
           </a:solidFill>
           <a:ln/>
         </p:spPr>
+        <p:txBody>
+          <a:bodyPr/>
+          <a:p/>
+        </p:txBody>
       </p:sp>
       <p:sp>
         <p:nvSpPr>
@@ -4117,6 +4197,10 @@
           </a:solidFill>
           <a:ln/>
         </p:spPr>
+        <p:txBody>
+          <a:bodyPr/>
+          <a:p/>
+        </p:txBody>
       </p:sp>
       <p:pic>
         <p:nvPicPr>
@@ -4278,6 +4362,10 @@
           </a:solidFill>
           <a:ln/>
         </p:spPr>
+        <p:txBody>
+          <a:bodyPr/>
+          <a:p/>
+        </p:txBody>
       </p:sp>
       <p:sp>
         <p:nvSpPr>
@@ -4298,6 +4386,10 @@
           </a:solidFill>
           <a:ln/>
         </p:spPr>
+        <p:txBody>
+          <a:bodyPr/>
+          <a:p/>
+        </p:txBody>
       </p:sp>
       <p:sp>
         <p:nvSpPr>
@@ -4320,6 +4412,10 @@
           </a:solidFill>
           <a:ln/>
         </p:spPr>
+        <p:txBody>
+          <a:bodyPr/>
+          <a:p/>
+        </p:txBody>
       </p:sp>
       <p:pic>
         <p:nvPicPr>
@@ -4481,6 +4577,10 @@
           </a:solidFill>
           <a:ln/>
         </p:spPr>
+        <p:txBody>
+          <a:bodyPr/>
+          <a:p/>
+        </p:txBody>
       </p:sp>
       <p:sp>
         <p:nvSpPr>
@@ -4501,6 +4601,10 @@
           </a:solidFill>
           <a:ln/>
         </p:spPr>
+        <p:txBody>
+          <a:bodyPr/>
+          <a:p/>
+        </p:txBody>
       </p:sp>
       <p:sp>
         <p:nvSpPr>
@@ -4523,6 +4627,10 @@
           </a:solidFill>
           <a:ln/>
         </p:spPr>
+        <p:txBody>
+          <a:bodyPr/>
+          <a:p/>
+        </p:txBody>
       </p:sp>
       <p:pic>
         <p:nvPicPr>
@@ -4684,6 +4792,10 @@
           </a:solidFill>
           <a:ln/>
         </p:spPr>
+        <p:txBody>
+          <a:bodyPr/>
+          <a:p/>
+        </p:txBody>
       </p:sp>
       <p:sp>
         <p:nvSpPr>
@@ -4704,6 +4816,10 @@
           </a:solidFill>
           <a:ln/>
         </p:spPr>
+        <p:txBody>
+          <a:bodyPr/>
+          <a:p/>
+        </p:txBody>
       </p:sp>
       <p:sp>
         <p:nvSpPr>
@@ -4726,6 +4842,10 @@
           </a:solidFill>
           <a:ln/>
         </p:spPr>
+        <p:txBody>
+          <a:bodyPr/>
+          <a:p/>
+        </p:txBody>
       </p:sp>
       <p:pic>
         <p:nvPicPr>
@@ -4972,7 +5092,7 @@
                 <a:ea typeface="Calibri" pitchFamily="34" charset="-122"/>
                 <a:cs typeface="Calibri" pitchFamily="34" charset="-120"/>
               </a:rPr>
-              <a:t>Extends existing DDG tiers with new enterprise revenue</a:t>
+              <a:t>Extends existing QQM tiers with new enterprise revenue</a:t>
             </a:r>
             <a:endParaRPr lang="en-US" sz="1300" dirty="0"/>
           </a:p>
@@ -4997,6 +5117,10 @@
           </a:solidFill>
           <a:ln/>
         </p:spPr>
+        <p:txBody>
+          <a:bodyPr/>
+          <a:p/>
+        </p:txBody>
       </p:sp>
       <p:sp>
         <p:nvSpPr>
@@ -5215,6 +5339,10 @@
           </a:solidFill>
           <a:ln/>
         </p:spPr>
+        <p:txBody>
+          <a:bodyPr/>
+          <a:p/>
+        </p:txBody>
       </p:sp>
       <p:sp>
         <p:nvSpPr>
@@ -5433,6 +5561,10 @@
           </a:solidFill>
           <a:ln/>
         </p:spPr>
+        <p:txBody>
+          <a:bodyPr/>
+          <a:p/>
+        </p:txBody>
       </p:sp>
       <p:sp>
         <p:nvSpPr>
@@ -5658,6 +5790,10 @@
             </a:outerShdw>
           </a:effectLst>
         </p:spPr>
+        <p:txBody>
+          <a:bodyPr/>
+          <a:p/>
+        </p:txBody>
       </p:sp>
       <p:sp>
         <p:nvSpPr>
@@ -5678,6 +5814,10 @@
           </a:solidFill>
           <a:ln/>
         </p:spPr>
+        <p:txBody>
+          <a:bodyPr/>
+          <a:p/>
+        </p:txBody>
       </p:sp>
       <p:sp>
         <p:nvSpPr>
@@ -5896,6 +6036,10 @@
           </a:solidFill>
           <a:ln/>
         </p:spPr>
+        <p:txBody>
+          <a:bodyPr/>
+          <a:p/>
+        </p:txBody>
       </p:sp>
       <p:sp>
         <p:nvSpPr>
@@ -6201,6 +6345,10 @@
           </a:solidFill>
           <a:ln/>
         </p:spPr>
+        <p:txBody>
+          <a:bodyPr/>
+          <a:p/>
+        </p:txBody>
       </p:sp>
       <p:sp>
         <p:nvSpPr>
@@ -6338,6 +6486,10 @@
           </a:solidFill>
           <a:ln/>
         </p:spPr>
+        <p:txBody>
+          <a:bodyPr/>
+          <a:p/>
+        </p:txBody>
       </p:sp>
       <p:sp>
         <p:nvSpPr>
@@ -6475,6 +6627,10 @@
           </a:solidFill>
           <a:ln/>
         </p:spPr>
+        <p:txBody>
+          <a:bodyPr/>
+          <a:p/>
+        </p:txBody>
       </p:sp>
       <p:sp>
         <p:nvSpPr>
@@ -9863,6 +10019,10 @@
             </a:outerShdw>
           </a:effectLst>
         </p:spPr>
+        <p:txBody>
+          <a:bodyPr/>
+          <a:p/>
+        </p:txBody>
       </p:sp>
       <p:sp>
         <p:nvSpPr>
@@ -9885,6 +10045,10 @@
           </a:solidFill>
           <a:ln/>
         </p:spPr>
+        <p:txBody>
+          <a:bodyPr/>
+          <a:p/>
+        </p:txBody>
       </p:sp>
       <p:pic>
         <p:nvPicPr>
@@ -10195,6 +10359,10 @@
             </a:outerShdw>
           </a:effectLst>
         </p:spPr>
+        <p:txBody>
+          <a:bodyPr/>
+          <a:p/>
+        </p:txBody>
       </p:sp>
       <p:sp>
         <p:nvSpPr>
@@ -10217,6 +10385,10 @@
           </a:solidFill>
           <a:ln/>
         </p:spPr>
+        <p:txBody>
+          <a:bodyPr/>
+          <a:p/>
+        </p:txBody>
       </p:sp>
       <p:pic>
         <p:nvPicPr>
@@ -10627,6 +10799,10 @@
           </a:solidFill>
           <a:ln/>
         </p:spPr>
+        <p:txBody>
+          <a:bodyPr/>
+          <a:p/>
+        </p:txBody>
       </p:sp>
       <p:sp>
         <p:nvSpPr>
@@ -10647,6 +10823,10 @@
           </a:solidFill>
           <a:ln/>
         </p:spPr>
+        <p:txBody>
+          <a:bodyPr/>
+          <a:p/>
+        </p:txBody>
       </p:sp>
       <p:pic>
         <p:nvPicPr>
@@ -10691,6 +10871,10 @@
           </a:solidFill>
           <a:ln/>
         </p:spPr>
+        <p:txBody>
+          <a:bodyPr/>
+          <a:p/>
+        </p:txBody>
       </p:sp>
       <p:sp>
         <p:nvSpPr>
@@ -10711,6 +10895,10 @@
           </a:solidFill>
           <a:ln/>
         </p:spPr>
+        <p:txBody>
+          <a:bodyPr/>
+          <a:p/>
+        </p:txBody>
       </p:sp>
       <p:sp>
         <p:nvSpPr>
@@ -10851,6 +11039,10 @@
           </a:solidFill>
           <a:ln/>
         </p:spPr>
+        <p:txBody>
+          <a:bodyPr/>
+          <a:p/>
+        </p:txBody>
       </p:sp>
       <p:sp>
         <p:nvSpPr>
@@ -10871,6 +11063,10 @@
           </a:solidFill>
           <a:ln/>
         </p:spPr>
+        <p:txBody>
+          <a:bodyPr/>
+          <a:p/>
+        </p:txBody>
       </p:sp>
       <p:pic>
         <p:nvPicPr>
@@ -10915,6 +11111,10 @@
           </a:solidFill>
           <a:ln/>
         </p:spPr>
+        <p:txBody>
+          <a:bodyPr/>
+          <a:p/>
+        </p:txBody>
       </p:sp>
       <p:sp>
         <p:nvSpPr>
@@ -10935,6 +11135,10 @@
           </a:solidFill>
           <a:ln/>
         </p:spPr>
+        <p:txBody>
+          <a:bodyPr/>
+          <a:p/>
+        </p:txBody>
       </p:sp>
       <p:sp>
         <p:nvSpPr>
@@ -11075,6 +11279,10 @@
           </a:solidFill>
           <a:ln/>
         </p:spPr>
+        <p:txBody>
+          <a:bodyPr/>
+          <a:p/>
+        </p:txBody>
       </p:sp>
       <p:sp>
         <p:nvSpPr>
@@ -11095,6 +11303,10 @@
           </a:solidFill>
           <a:ln/>
         </p:spPr>
+        <p:txBody>
+          <a:bodyPr/>
+          <a:p/>
+        </p:txBody>
       </p:sp>
       <p:pic>
         <p:nvPicPr>
@@ -11139,6 +11351,10 @@
           </a:solidFill>
           <a:ln/>
         </p:spPr>
+        <p:txBody>
+          <a:bodyPr/>
+          <a:p/>
+        </p:txBody>
       </p:sp>
       <p:sp>
         <p:nvSpPr>
@@ -11159,6 +11375,10 @@
           </a:solidFill>
           <a:ln/>
         </p:spPr>
+        <p:txBody>
+          <a:bodyPr/>
+          <a:p/>
+        </p:txBody>
       </p:sp>
       <p:sp>
         <p:nvSpPr>
@@ -11299,6 +11519,10 @@
           </a:solidFill>
           <a:ln/>
         </p:spPr>
+        <p:txBody>
+          <a:bodyPr/>
+          <a:p/>
+        </p:txBody>
       </p:sp>
       <p:sp>
         <p:nvSpPr>
@@ -11319,6 +11543,10 @@
           </a:solidFill>
           <a:ln/>
         </p:spPr>
+        <p:txBody>
+          <a:bodyPr/>
+          <a:p/>
+        </p:txBody>
       </p:sp>
       <p:pic>
         <p:nvPicPr>
@@ -11363,6 +11591,10 @@
           </a:solidFill>
           <a:ln/>
         </p:spPr>
+        <p:txBody>
+          <a:bodyPr/>
+          <a:p/>
+        </p:txBody>
       </p:sp>
       <p:sp>
         <p:nvSpPr>
@@ -11383,6 +11615,10 @@
           </a:solidFill>
           <a:ln/>
         </p:spPr>
+        <p:txBody>
+          <a:bodyPr/>
+          <a:p/>
+        </p:txBody>
       </p:sp>
       <p:sp>
         <p:nvSpPr>

</xml_diff>